<commit_message>
session-01: update deck with embedded images + add source PNGs
Co-Authored-By: Claude Opus 4.7 (1M context) <noreply@anthropic.com>
</commit_message>
<xml_diff>
--- a/session-01/claude-code-deck1-he.pptx
+++ b/session-01/claude-code-deck1-he.pptx
@@ -3108,7 +3108,7 @@
           <a:p>
             <a:fld id="{C764DE79-268F-4C1A-8933-263129D2AF90}" type="datetimeFigureOut">
               <a:rPr lang="en-US" smtClean="0"/>
-              <a:t>5/7/26</a:t>
+              <a:t>5/9/26</a:t>
             </a:fld>
             <a:endParaRPr lang="en-US" dirty="0"/>
           </a:p>
@@ -3309,7 +3309,7 @@
           <a:p>
             <a:fld id="{C764DE79-268F-4C1A-8933-263129D2AF90}" type="datetimeFigureOut">
               <a:rPr lang="en-US" smtClean="0"/>
-              <a:t>5/7/26</a:t>
+              <a:t>5/9/26</a:t>
             </a:fld>
             <a:endParaRPr lang="en-US" dirty="0"/>
           </a:p>
@@ -3520,7 +3520,7 @@
           <a:p>
             <a:fld id="{C764DE79-268F-4C1A-8933-263129D2AF90}" type="datetimeFigureOut">
               <a:rPr lang="en-US" smtClean="0"/>
-              <a:t>5/7/26</a:t>
+              <a:t>5/9/26</a:t>
             </a:fld>
             <a:endParaRPr lang="en-US" dirty="0"/>
           </a:p>
@@ -3756,7 +3756,7 @@
           <a:p>
             <a:fld id="{C764DE79-268F-4C1A-8933-263129D2AF90}" type="datetimeFigureOut">
               <a:rPr lang="en-US" smtClean="0"/>
-              <a:t>5/7/26</a:t>
+              <a:t>5/9/26</a:t>
             </a:fld>
             <a:endParaRPr lang="en-US" dirty="0"/>
           </a:p>
@@ -4033,7 +4033,7 @@
           <a:p>
             <a:fld id="{C764DE79-268F-4C1A-8933-263129D2AF90}" type="datetimeFigureOut">
               <a:rPr lang="en-US" smtClean="0"/>
-              <a:t>5/7/26</a:t>
+              <a:t>5/9/26</a:t>
             </a:fld>
             <a:endParaRPr lang="en-US" dirty="0"/>
           </a:p>
@@ -4302,7 +4302,7 @@
           <a:p>
             <a:fld id="{C764DE79-268F-4C1A-8933-263129D2AF90}" type="datetimeFigureOut">
               <a:rPr lang="en-US" smtClean="0"/>
-              <a:t>5/7/26</a:t>
+              <a:t>5/9/26</a:t>
             </a:fld>
             <a:endParaRPr lang="en-US" dirty="0"/>
           </a:p>
@@ -4718,7 +4718,7 @@
           <a:p>
             <a:fld id="{C764DE79-268F-4C1A-8933-263129D2AF90}" type="datetimeFigureOut">
               <a:rPr lang="en-US" smtClean="0"/>
-              <a:t>5/7/26</a:t>
+              <a:t>5/9/26</a:t>
             </a:fld>
             <a:endParaRPr lang="en-US" dirty="0"/>
           </a:p>
@@ -4861,7 +4861,7 @@
           <a:p>
             <a:fld id="{C764DE79-268F-4C1A-8933-263129D2AF90}" type="datetimeFigureOut">
               <a:rPr lang="en-US" smtClean="0"/>
-              <a:t>5/7/26</a:t>
+              <a:t>5/9/26</a:t>
             </a:fld>
             <a:endParaRPr lang="en-US" dirty="0"/>
           </a:p>
@@ -4975,7 +4975,7 @@
           <a:p>
             <a:fld id="{C764DE79-268F-4C1A-8933-263129D2AF90}" type="datetimeFigureOut">
               <a:rPr lang="en-US" smtClean="0"/>
-              <a:t>5/7/26</a:t>
+              <a:t>5/9/26</a:t>
             </a:fld>
             <a:endParaRPr lang="en-US" dirty="0"/>
           </a:p>
@@ -5289,7 +5289,7 @@
           <a:p>
             <a:fld id="{C764DE79-268F-4C1A-8933-263129D2AF90}" type="datetimeFigureOut">
               <a:rPr lang="en-US" smtClean="0"/>
-              <a:t>5/7/26</a:t>
+              <a:t>5/9/26</a:t>
             </a:fld>
             <a:endParaRPr lang="en-US" dirty="0"/>
           </a:p>
@@ -5579,7 +5579,7 @@
           <a:p>
             <a:fld id="{C764DE79-268F-4C1A-8933-263129D2AF90}" type="datetimeFigureOut">
               <a:rPr lang="en-US" smtClean="0"/>
-              <a:t>5/7/26</a:t>
+              <a:t>5/9/26</a:t>
             </a:fld>
             <a:endParaRPr lang="en-US" dirty="0"/>
           </a:p>
@@ -5823,7 +5823,7 @@
           <a:p>
             <a:fld id="{C764DE79-268F-4C1A-8933-263129D2AF90}" type="datetimeFigureOut">
               <a:rPr lang="en-US" smtClean="0"/>
-              <a:t>5/7/26</a:t>
+              <a:t>5/9/26</a:t>
             </a:fld>
             <a:endParaRPr lang="en-US" dirty="0"/>
           </a:p>
@@ -17349,30 +17349,6 @@
           </a:p>
         </p:txBody>
       </p:sp>
-      <p:pic>
-        <p:nvPicPr>
-          <p:cNvPr id="8" name="Image 0" descr="./anthropic-naive.png"/>
-          <p:cNvPicPr>
-            <a:picLocks noChangeAspect="1"/>
-          </p:cNvPicPr>
-          <p:nvPr/>
-        </p:nvPicPr>
-        <p:blipFill>
-          <a:blip/>
-          <a:stretch>
-            <a:fillRect/>
-          </a:stretch>
-        </p:blipFill>
-        <p:spPr>
-          <a:xfrm>
-            <a:off x="6355080" y="3108960"/>
-            <a:ext cx="5212080" cy="2331720"/>
-          </a:xfrm>
-          <a:prstGeom prst="rect">
-            <a:avLst/>
-          </a:prstGeom>
-        </p:spPr>
-      </p:pic>
       <p:sp>
         <p:nvSpPr>
           <p:cNvPr id="9" name="Shape 6"/>
@@ -17483,30 +17459,6 @@
           </a:p>
         </p:txBody>
       </p:sp>
-      <p:pic>
-        <p:nvPicPr>
-          <p:cNvPr id="12" name="Image 1" descr="./anthropic-structured.png"/>
-          <p:cNvPicPr>
-            <a:picLocks noChangeAspect="1"/>
-          </p:cNvPicPr>
-          <p:nvPr/>
-        </p:nvPicPr>
-        <p:blipFill>
-          <a:blip/>
-          <a:stretch>
-            <a:fillRect/>
-          </a:stretch>
-        </p:blipFill>
-        <p:spPr>
-          <a:xfrm>
-            <a:off x="594360" y="3108960"/>
-            <a:ext cx="5212080" cy="2331720"/>
-          </a:xfrm>
-          <a:prstGeom prst="rect">
-            <a:avLst/>
-          </a:prstGeom>
-        </p:spPr>
-      </p:pic>
       <p:sp>
         <p:nvSpPr>
           <p:cNvPr id="13" name="Shape 9"/>
@@ -17617,6 +17569,66 @@
           </a:p>
         </p:txBody>
       </p:sp>
+      <p:pic>
+        <p:nvPicPr>
+          <p:cNvPr id="17" name="Picture 16" descr="A screenshot of a computer&#10;&#10;AI-generated content may be incorrect.">
+            <a:extLst>
+              <a:ext uri="{FF2B5EF4-FFF2-40B4-BE49-F238E27FC236}">
+                <a16:creationId xmlns:a16="http://schemas.microsoft.com/office/drawing/2014/main" id="{AD23FEB4-E1AA-FDC5-0A85-E938B59EA708}"/>
+              </a:ext>
+            </a:extLst>
+          </p:cNvPr>
+          <p:cNvPicPr>
+            <a:picLocks noChangeAspect="1"/>
+          </p:cNvPicPr>
+          <p:nvPr/>
+        </p:nvPicPr>
+        <p:blipFill>
+          <a:blip r:embed="rId3"/>
+          <a:stretch>
+            <a:fillRect/>
+          </a:stretch>
+        </p:blipFill>
+        <p:spPr>
+          <a:xfrm>
+            <a:off x="6727345" y="2927147"/>
+            <a:ext cx="4467550" cy="2466745"/>
+          </a:xfrm>
+          <a:prstGeom prst="rect">
+            <a:avLst/>
+          </a:prstGeom>
+        </p:spPr>
+      </p:pic>
+      <p:pic>
+        <p:nvPicPr>
+          <p:cNvPr id="19" name="Picture 18" descr="A screenshot of a computer&#10;&#10;AI-generated content may be incorrect.">
+            <a:extLst>
+              <a:ext uri="{FF2B5EF4-FFF2-40B4-BE49-F238E27FC236}">
+                <a16:creationId xmlns:a16="http://schemas.microsoft.com/office/drawing/2014/main" id="{8339AFDB-D3D4-27E1-D52D-A676663B987F}"/>
+              </a:ext>
+            </a:extLst>
+          </p:cNvPr>
+          <p:cNvPicPr>
+            <a:picLocks noChangeAspect="1"/>
+          </p:cNvPicPr>
+          <p:nvPr/>
+        </p:nvPicPr>
+        <p:blipFill>
+          <a:blip r:embed="rId4"/>
+          <a:stretch>
+            <a:fillRect/>
+          </a:stretch>
+        </p:blipFill>
+        <p:spPr>
+          <a:xfrm>
+            <a:off x="1095530" y="3018513"/>
+            <a:ext cx="4209740" cy="2375455"/>
+          </a:xfrm>
+          <a:prstGeom prst="rect">
+            <a:avLst/>
+          </a:prstGeom>
+        </p:spPr>
+      </p:pic>
     </p:spTree>
   </p:cSld>
   <p:clrMapOvr>
@@ -20571,108 +20583,114 @@
           </a:p>
         </p:txBody>
       </p:sp>
+      <p:sp>
+        <p:nvSpPr>
+          <p:cNvPr id="23" name="Text 20"/>
+          <p:cNvSpPr/>
+          <p:nvPr/>
+        </p:nvSpPr>
+        <p:spPr>
+          <a:xfrm>
+            <a:off x="6217920" y="6446520"/>
+            <a:ext cx="5486400" cy="274320"/>
+          </a:xfrm>
+          <a:prstGeom prst="rect">
+            <a:avLst/>
+          </a:prstGeom>
+          <a:noFill/>
+          <a:ln/>
+        </p:spPr>
+        <p:txBody>
+          <a:bodyPr wrap="square" lIns="0" tIns="0" rIns="0" bIns="0" rtlCol="0" anchor="ctr"/>
+          <a:lstStyle/>
+          <a:p>
+            <a:pPr marL="0" indent="0" algn="r" rtl="1">
+              <a:buNone/>
+            </a:pPr>
+            <a:r>
+              <a:rPr lang="en-US" sz="900" dirty="0">
+                <a:solidFill>
+                  <a:srgbClr val="5C564D"/>
+                </a:solidFill>
+                <a:latin typeface="Arial" pitchFamily="34" charset="0"/>
+                <a:ea typeface="Arial" pitchFamily="34" charset="-122"/>
+                <a:cs typeface="Arial" pitchFamily="34" charset="-120"/>
+              </a:rPr>
+              <a:t>Claude Code - יסודות</a:t>
+            </a:r>
+            <a:endParaRPr lang="en-US" sz="900" dirty="0"/>
+          </a:p>
+        </p:txBody>
+      </p:sp>
+      <p:sp>
+        <p:nvSpPr>
+          <p:cNvPr id="24" name="Text 21"/>
+          <p:cNvSpPr/>
+          <p:nvPr/>
+        </p:nvSpPr>
+        <p:spPr>
+          <a:xfrm>
+            <a:off x="457200" y="6446520"/>
+            <a:ext cx="548640" cy="274320"/>
+          </a:xfrm>
+          <a:prstGeom prst="rect">
+            <a:avLst/>
+          </a:prstGeom>
+          <a:noFill/>
+          <a:ln/>
+        </p:spPr>
+        <p:txBody>
+          <a:bodyPr wrap="square" lIns="0" tIns="0" rIns="0" bIns="0" rtlCol="0" anchor="ctr"/>
+          <a:lstStyle/>
+          <a:p>
+            <a:pPr marL="0" indent="0" algn="l">
+              <a:buNone/>
+            </a:pPr>
+            <a:r>
+              <a:rPr lang="en-US" sz="900" dirty="0">
+                <a:solidFill>
+                  <a:srgbClr val="5C564D"/>
+                </a:solidFill>
+                <a:latin typeface="Arial" pitchFamily="34" charset="0"/>
+                <a:ea typeface="Arial" pitchFamily="34" charset="-122"/>
+                <a:cs typeface="Arial" pitchFamily="34" charset="-120"/>
+              </a:rPr>
+              <a:t>21</a:t>
+            </a:r>
+            <a:endParaRPr lang="en-US" sz="900" dirty="0"/>
+          </a:p>
+        </p:txBody>
+      </p:sp>
       <p:pic>
         <p:nvPicPr>
-          <p:cNvPr id="22" name="Image 0" descr="./code-naive-response.png"/>
+          <p:cNvPr id="26" name="Picture 25" descr="A screenshot of a black screen&#10;&#10;AI-generated content may be incorrect.">
+            <a:extLst>
+              <a:ext uri="{FF2B5EF4-FFF2-40B4-BE49-F238E27FC236}">
+                <a16:creationId xmlns:a16="http://schemas.microsoft.com/office/drawing/2014/main" id="{6DDBEAF0-0CB1-3E9C-C012-6042D69AF16D}"/>
+              </a:ext>
+            </a:extLst>
+          </p:cNvPr>
           <p:cNvPicPr>
             <a:picLocks noChangeAspect="1"/>
           </p:cNvPicPr>
           <p:nvPr/>
         </p:nvPicPr>
         <p:blipFill>
-          <a:blip/>
+          <a:blip r:embed="rId3"/>
           <a:stretch>
             <a:fillRect/>
           </a:stretch>
         </p:blipFill>
         <p:spPr>
           <a:xfrm>
-            <a:off x="594360" y="2103120"/>
-            <a:ext cx="5212080" cy="4069080"/>
+            <a:off x="1632632" y="2097916"/>
+            <a:ext cx="3011139" cy="4067843"/>
           </a:xfrm>
           <a:prstGeom prst="rect">
             <a:avLst/>
           </a:prstGeom>
         </p:spPr>
       </p:pic>
-      <p:sp>
-        <p:nvSpPr>
-          <p:cNvPr id="23" name="Text 20"/>
-          <p:cNvSpPr/>
-          <p:nvPr/>
-        </p:nvSpPr>
-        <p:spPr>
-          <a:xfrm>
-            <a:off x="6217920" y="6446520"/>
-            <a:ext cx="5486400" cy="274320"/>
-          </a:xfrm>
-          <a:prstGeom prst="rect">
-            <a:avLst/>
-          </a:prstGeom>
-          <a:noFill/>
-          <a:ln/>
-        </p:spPr>
-        <p:txBody>
-          <a:bodyPr wrap="square" lIns="0" tIns="0" rIns="0" bIns="0" rtlCol="0" anchor="ctr"/>
-          <a:lstStyle/>
-          <a:p>
-            <a:pPr marL="0" indent="0" algn="r" rtl="1">
-              <a:buNone/>
-            </a:pPr>
-            <a:r>
-              <a:rPr lang="en-US" sz="900" dirty="0">
-                <a:solidFill>
-                  <a:srgbClr val="5C564D"/>
-                </a:solidFill>
-                <a:latin typeface="Arial" pitchFamily="34" charset="0"/>
-                <a:ea typeface="Arial" pitchFamily="34" charset="-122"/>
-                <a:cs typeface="Arial" pitchFamily="34" charset="-120"/>
-              </a:rPr>
-              <a:t>Claude Code - יסודות</a:t>
-            </a:r>
-            <a:endParaRPr lang="en-US" sz="900" dirty="0"/>
-          </a:p>
-        </p:txBody>
-      </p:sp>
-      <p:sp>
-        <p:nvSpPr>
-          <p:cNvPr id="24" name="Text 21"/>
-          <p:cNvSpPr/>
-          <p:nvPr/>
-        </p:nvSpPr>
-        <p:spPr>
-          <a:xfrm>
-            <a:off x="457200" y="6446520"/>
-            <a:ext cx="548640" cy="274320"/>
-          </a:xfrm>
-          <a:prstGeom prst="rect">
-            <a:avLst/>
-          </a:prstGeom>
-          <a:noFill/>
-          <a:ln/>
-        </p:spPr>
-        <p:txBody>
-          <a:bodyPr wrap="square" lIns="0" tIns="0" rIns="0" bIns="0" rtlCol="0" anchor="ctr"/>
-          <a:lstStyle/>
-          <a:p>
-            <a:pPr marL="0" indent="0" algn="l">
-              <a:buNone/>
-            </a:pPr>
-            <a:r>
-              <a:rPr lang="en-US" sz="900" dirty="0">
-                <a:solidFill>
-                  <a:srgbClr val="5C564D"/>
-                </a:solidFill>
-                <a:latin typeface="Arial" pitchFamily="34" charset="0"/>
-                <a:ea typeface="Arial" pitchFamily="34" charset="-122"/>
-                <a:cs typeface="Arial" pitchFamily="34" charset="-120"/>
-              </a:rPr>
-              <a:t>21</a:t>
-            </a:r>
-            <a:endParaRPr lang="en-US" sz="900" dirty="0"/>
-          </a:p>
-        </p:txBody>
-      </p:sp>
     </p:spTree>
   </p:cSld>
   <p:clrMapOvr>
@@ -21472,108 +21490,114 @@
           </a:p>
         </p:txBody>
       </p:sp>
+      <p:sp>
+        <p:nvSpPr>
+          <p:cNvPr id="23" name="Text 20"/>
+          <p:cNvSpPr/>
+          <p:nvPr/>
+        </p:nvSpPr>
+        <p:spPr>
+          <a:xfrm>
+            <a:off x="6217920" y="6446520"/>
+            <a:ext cx="5486400" cy="274320"/>
+          </a:xfrm>
+          <a:prstGeom prst="rect">
+            <a:avLst/>
+          </a:prstGeom>
+          <a:noFill/>
+          <a:ln/>
+        </p:spPr>
+        <p:txBody>
+          <a:bodyPr wrap="square" lIns="0" tIns="0" rIns="0" bIns="0" rtlCol="0" anchor="ctr"/>
+          <a:lstStyle/>
+          <a:p>
+            <a:pPr marL="0" indent="0" algn="r" rtl="1">
+              <a:buNone/>
+            </a:pPr>
+            <a:r>
+              <a:rPr lang="en-US" sz="900" dirty="0">
+                <a:solidFill>
+                  <a:srgbClr val="9B9588"/>
+                </a:solidFill>
+                <a:latin typeface="Arial" pitchFamily="34" charset="0"/>
+                <a:ea typeface="Arial" pitchFamily="34" charset="-122"/>
+                <a:cs typeface="Arial" pitchFamily="34" charset="-120"/>
+              </a:rPr>
+              <a:t>Claude Code - יסודות</a:t>
+            </a:r>
+            <a:endParaRPr lang="en-US" sz="900" dirty="0"/>
+          </a:p>
+        </p:txBody>
+      </p:sp>
+      <p:sp>
+        <p:nvSpPr>
+          <p:cNvPr id="24" name="Text 21"/>
+          <p:cNvSpPr/>
+          <p:nvPr/>
+        </p:nvSpPr>
+        <p:spPr>
+          <a:xfrm>
+            <a:off x="457200" y="6446520"/>
+            <a:ext cx="548640" cy="274320"/>
+          </a:xfrm>
+          <a:prstGeom prst="rect">
+            <a:avLst/>
+          </a:prstGeom>
+          <a:noFill/>
+          <a:ln/>
+        </p:spPr>
+        <p:txBody>
+          <a:bodyPr wrap="square" lIns="0" tIns="0" rIns="0" bIns="0" rtlCol="0" anchor="ctr"/>
+          <a:lstStyle/>
+          <a:p>
+            <a:pPr marL="0" indent="0" algn="l">
+              <a:buNone/>
+            </a:pPr>
+            <a:r>
+              <a:rPr lang="en-US" sz="900" dirty="0">
+                <a:solidFill>
+                  <a:srgbClr val="9B9588"/>
+                </a:solidFill>
+                <a:latin typeface="Arial" pitchFamily="34" charset="0"/>
+                <a:ea typeface="Arial" pitchFamily="34" charset="-122"/>
+                <a:cs typeface="Arial" pitchFamily="34" charset="-120"/>
+              </a:rPr>
+              <a:t>22</a:t>
+            </a:r>
+            <a:endParaRPr lang="en-US" sz="900" dirty="0"/>
+          </a:p>
+        </p:txBody>
+      </p:sp>
       <p:pic>
         <p:nvPicPr>
-          <p:cNvPr id="22" name="Image 0" descr="./code-structured-response.png"/>
+          <p:cNvPr id="26" name="Picture 25" descr="A screenshot of a black screen&#10;&#10;AI-generated content may be incorrect.">
+            <a:extLst>
+              <a:ext uri="{FF2B5EF4-FFF2-40B4-BE49-F238E27FC236}">
+                <a16:creationId xmlns:a16="http://schemas.microsoft.com/office/drawing/2014/main" id="{BE0271A0-ABD1-3B8A-EDD3-5EBBBA7DE1D1}"/>
+              </a:ext>
+            </a:extLst>
+          </p:cNvPr>
           <p:cNvPicPr>
             <a:picLocks noChangeAspect="1"/>
           </p:cNvPicPr>
           <p:nvPr/>
         </p:nvPicPr>
         <p:blipFill>
-          <a:blip/>
+          <a:blip r:embed="rId3"/>
           <a:stretch>
             <a:fillRect/>
           </a:stretch>
         </p:blipFill>
         <p:spPr>
           <a:xfrm>
-            <a:off x="594360" y="2103120"/>
-            <a:ext cx="5212080" cy="4069080"/>
+            <a:off x="883734" y="2034159"/>
+            <a:ext cx="3093843" cy="4179570"/>
           </a:xfrm>
           <a:prstGeom prst="rect">
             <a:avLst/>
           </a:prstGeom>
         </p:spPr>
       </p:pic>
-      <p:sp>
-        <p:nvSpPr>
-          <p:cNvPr id="23" name="Text 20"/>
-          <p:cNvSpPr/>
-          <p:nvPr/>
-        </p:nvSpPr>
-        <p:spPr>
-          <a:xfrm>
-            <a:off x="6217920" y="6446520"/>
-            <a:ext cx="5486400" cy="274320"/>
-          </a:xfrm>
-          <a:prstGeom prst="rect">
-            <a:avLst/>
-          </a:prstGeom>
-          <a:noFill/>
-          <a:ln/>
-        </p:spPr>
-        <p:txBody>
-          <a:bodyPr wrap="square" lIns="0" tIns="0" rIns="0" bIns="0" rtlCol="0" anchor="ctr"/>
-          <a:lstStyle/>
-          <a:p>
-            <a:pPr marL="0" indent="0" algn="r" rtl="1">
-              <a:buNone/>
-            </a:pPr>
-            <a:r>
-              <a:rPr lang="en-US" sz="900" dirty="0">
-                <a:solidFill>
-                  <a:srgbClr val="9B9588"/>
-                </a:solidFill>
-                <a:latin typeface="Arial" pitchFamily="34" charset="0"/>
-                <a:ea typeface="Arial" pitchFamily="34" charset="-122"/>
-                <a:cs typeface="Arial" pitchFamily="34" charset="-120"/>
-              </a:rPr>
-              <a:t>Claude Code - יסודות</a:t>
-            </a:r>
-            <a:endParaRPr lang="en-US" sz="900" dirty="0"/>
-          </a:p>
-        </p:txBody>
-      </p:sp>
-      <p:sp>
-        <p:nvSpPr>
-          <p:cNvPr id="24" name="Text 21"/>
-          <p:cNvSpPr/>
-          <p:nvPr/>
-        </p:nvSpPr>
-        <p:spPr>
-          <a:xfrm>
-            <a:off x="457200" y="6446520"/>
-            <a:ext cx="548640" cy="274320"/>
-          </a:xfrm>
-          <a:prstGeom prst="rect">
-            <a:avLst/>
-          </a:prstGeom>
-          <a:noFill/>
-          <a:ln/>
-        </p:spPr>
-        <p:txBody>
-          <a:bodyPr wrap="square" lIns="0" tIns="0" rIns="0" bIns="0" rtlCol="0" anchor="ctr"/>
-          <a:lstStyle/>
-          <a:p>
-            <a:pPr marL="0" indent="0" algn="l">
-              <a:buNone/>
-            </a:pPr>
-            <a:r>
-              <a:rPr lang="en-US" sz="900" dirty="0">
-                <a:solidFill>
-                  <a:srgbClr val="9B9588"/>
-                </a:solidFill>
-                <a:latin typeface="Arial" pitchFamily="34" charset="0"/>
-                <a:ea typeface="Arial" pitchFamily="34" charset="-122"/>
-                <a:cs typeface="Arial" pitchFamily="34" charset="-120"/>
-              </a:rPr>
-              <a:t>22</a:t>
-            </a:r>
-            <a:endParaRPr lang="en-US" sz="900" dirty="0"/>
-          </a:p>
-        </p:txBody>
-      </p:sp>
     </p:spTree>
   </p:cSld>
   <p:clrMapOvr>

</xml_diff>

<commit_message>
session-01: reorder deck — prompting before Skills
Swaps Part 02 and Part 03 so students learn to prompt before
they package prompts as reusable Skills. Updates section dividers,
chapter prefixes, and the agenda slide to match.

Co-Authored-By: Claude Opus 4.7 (1M context) <noreply@anthropic.com>
</commit_message>
<xml_diff>
--- a/session-01/claude-code-deck1-he.pptx
+++ b/session-01/claude-code-deck1-he.pptx
@@ -28,13 +28,6 @@
     <p:sldId id="295" r:id="rId19"/>
     <p:sldId id="264" r:id="rId20"/>
     <p:sldId id="265" r:id="rId21"/>
-    <p:sldId id="266" r:id="rId22"/>
-    <p:sldId id="267" r:id="rId23"/>
-    <p:sldId id="268" r:id="rId24"/>
-    <p:sldId id="284" r:id="rId25"/>
-    <p:sldId id="285" r:id="rId26"/>
-    <p:sldId id="271" r:id="rId27"/>
-    <p:sldId id="272" r:id="rId28"/>
     <p:sldId id="273" r:id="rId29"/>
     <p:sldId id="275" r:id="rId30"/>
     <p:sldId id="274" r:id="rId31"/>
@@ -42,6 +35,13 @@
     <p:sldId id="277" r:id="rId33"/>
     <p:sldId id="278" r:id="rId34"/>
     <p:sldId id="279" r:id="rId35"/>
+    <p:sldId id="272" r:id="rId28"/>
+    <p:sldId id="266" r:id="rId22"/>
+    <p:sldId id="267" r:id="rId23"/>
+    <p:sldId id="268" r:id="rId24"/>
+    <p:sldId id="284" r:id="rId25"/>
+    <p:sldId id="285" r:id="rId26"/>
+    <p:sldId id="271" r:id="rId27"/>
     <p:sldId id="280" r:id="rId36"/>
     <p:sldId id="281" r:id="rId37"/>
     <p:sldId id="282" r:id="rId38"/>
@@ -19979,7 +19979,7 @@
                 <a:ea typeface="Arial" pitchFamily="34" charset="-122"/>
                 <a:cs typeface="Arial" pitchFamily="34" charset="-120"/>
               </a:rPr>
-              <a:t>חלק 02</a:t>
+              <a:t>חלק 03</a:t>
             </a:r>
             <a:endParaRPr lang="en-US" sz="1400" dirty="0"/>
           </a:p>
@@ -20129,7 +20129,7 @@
                 <a:ea typeface="Arial" pitchFamily="34" charset="-122"/>
                 <a:cs typeface="Arial" pitchFamily="34" charset="-120"/>
               </a:rPr>
-              <a:t>חלק 02  ·  מה זה</a:t>
+              <a:t>חלק 03  ·  מה זה</a:t>
             </a:r>
             <a:endParaRPr lang="en-US" sz="1100" dirty="0"/>
           </a:p>
@@ -20971,7 +20971,7 @@
                 <a:ea typeface="Arial" pitchFamily="34" charset="-122"/>
                 <a:cs typeface="Arial" pitchFamily="34" charset="-120"/>
               </a:rPr>
-              <a:t>חלק 02  ·  SKILL לדוגמה  ·  UI</a:t>
+              <a:t>חלק 03  ·  SKILL לדוגמה  ·  UI</a:t>
             </a:r>
             <a:endParaRPr lang="en-US" sz="1100" dirty="0"/>
           </a:p>
@@ -21894,7 +21894,7 @@
                 <a:ea typeface="Arial" pitchFamily="34" charset="-122"/>
                 <a:cs typeface="Arial" pitchFamily="34" charset="-120"/>
               </a:rPr>
-              <a:t>חלק 02  ·  SKILL לדוגמה  ·  CODE REVIEW</a:t>
+              <a:t>חלק 03  ·  SKILL לדוגמה  ·  CODE REVIEW</a:t>
             </a:r>
             <a:endParaRPr lang="en-US" sz="1100" dirty="0"/>
           </a:p>
@@ -22820,7 +22820,7 @@
                 <a:ea typeface="Arial" pitchFamily="34" charset="-122"/>
                 <a:cs typeface="Arial" pitchFamily="34" charset="-120"/>
               </a:rPr>
-              <a:t>חלק 02  ·  SKILL </a:t>
+              <a:t>חלק 03  ·  SKILL </a:t>
             </a:r>
             <a:r>
               <a:rPr lang="en-US" sz="1100" b="1" kern="0" spc="400" dirty="0" err="1">
@@ -23833,7 +23833,7 @@
                 <a:ea typeface="Arial" pitchFamily="34" charset="-122"/>
                 <a:cs typeface="Arial" pitchFamily="34" charset="-120"/>
               </a:rPr>
-              <a:t>חלק 02  ·  SKILL משלך</a:t>
+              <a:t>חלק 03  ·  SKILL משלך</a:t>
             </a:r>
             <a:endParaRPr lang="en-US" sz="1100" dirty="0"/>
           </a:p>
@@ -25138,7 +25138,7 @@
                 <a:ea typeface="Arial" pitchFamily="34" charset="-122"/>
                 <a:cs typeface="Arial" pitchFamily="34" charset="-120"/>
               </a:rPr>
-              <a:t>חלק 03</a:t>
+              <a:t>חלק 02</a:t>
             </a:r>
             <a:endParaRPr lang="en-US" sz="1400" dirty="0"/>
           </a:p>
@@ -25288,7 +25288,7 @@
                 <a:ea typeface="Arial" pitchFamily="34" charset="-122"/>
                 <a:cs typeface="Arial" pitchFamily="34" charset="-120"/>
               </a:rPr>
-              <a:t>חלק 03  ·  הדוגמה הקנונית</a:t>
+              <a:t>חלק 02  ·  הדוגמה הקנונית</a:t>
             </a:r>
             <a:endParaRPr lang="en-US" sz="1100" dirty="0"/>
           </a:p>
@@ -26510,7 +26510,7 @@
                 <a:ea typeface="Arial" pitchFamily="34" charset="-122"/>
                 <a:cs typeface="Arial" pitchFamily="34" charset="-120"/>
               </a:rPr>
-              <a:t>חלק 03  ·  המסגרת</a:t>
+              <a:t>חלק 02  ·  המסגרת</a:t>
             </a:r>
             <a:endParaRPr lang="en-US" sz="1100" dirty="0"/>
           </a:p>
@@ -28665,7 +28665,7 @@
                 <a:ea typeface="Arial" pitchFamily="34" charset="-122"/>
                 <a:cs typeface="Arial" pitchFamily="34" charset="-120"/>
               </a:rPr>
-              <a:t>חלק 03  ·  בקוד  ·  פרומפט נאיבי</a:t>
+              <a:t>חלק 02  ·  בקוד  ·  פרומפט נאיבי</a:t>
             </a:r>
             <a:endParaRPr lang="en-US" sz="1100" dirty="0"/>
           </a:p>
@@ -29572,7 +29572,7 @@
                 <a:ea typeface="Arial" pitchFamily="34" charset="-122"/>
                 <a:cs typeface="Arial" pitchFamily="34" charset="-120"/>
               </a:rPr>
-              <a:t>חלק 03  ·  בקוד  ·  פרומפט מובנה</a:t>
+              <a:t>חלק 02  ·  בקוד  ·  פרומפט מובנה</a:t>
             </a:r>
             <a:endParaRPr lang="en-US" sz="1100" dirty="0"/>
           </a:p>
@@ -30479,7 +30479,7 @@
                 <a:ea typeface="Arial" pitchFamily="34" charset="-122"/>
                 <a:cs typeface="Arial" pitchFamily="34" charset="-120"/>
               </a:rPr>
-              <a:t>חלק 03  ·  המסקנה</a:t>
+              <a:t>חלק 02  ·  המסקנה</a:t>
             </a:r>
             <a:endParaRPr lang="en-US" sz="1100" dirty="0"/>
           </a:p>
@@ -31617,7 +31617,7 @@
                 <a:ea typeface="Arial" pitchFamily="34" charset="-122"/>
                 <a:cs typeface="Arial" pitchFamily="34" charset="-120"/>
               </a:rPr>
-              <a:t>חלק 03  ·  תרגול</a:t>
+              <a:t>חלק 02  ·  תרגול</a:t>
             </a:r>
             <a:endParaRPr lang="en-US" sz="1100" dirty="0"/>
           </a:p>
@@ -35978,7 +35978,7 @@
                 <a:ea typeface="Arial" pitchFamily="34" charset="-122"/>
                 <a:cs typeface="Arial" pitchFamily="34" charset="-120"/>
               </a:rPr>
-              <a:t>Skills</a:t>
+              <a:t>הנחיה</a:t>
             </a:r>
             <a:endParaRPr lang="en-US" sz="2400" dirty="0"/>
           </a:p>
@@ -36049,7 +36049,7 @@
                 <a:ea typeface="Arial" pitchFamily="34" charset="-122"/>
                 <a:cs typeface="Arial" pitchFamily="34" charset="-120"/>
               </a:rPr>
-              <a:t>30 דק׳</a:t>
+              <a:t>50 דק׳</a:t>
             </a:r>
             <a:endParaRPr lang="en-US" sz="1100" dirty="0"/>
           </a:p>
@@ -36088,7 +36088,7 @@
                 <a:ea typeface="Arial" pitchFamily="34" charset="-122"/>
                 <a:cs typeface="Arial" pitchFamily="34" charset="-120"/>
               </a:rPr>
-              <a:t>מודולי מומחיות לשימוש חוזר. UI, code review, security audit.</a:t>
+              <a:t>מסגרת בת 10 רכיבים. דוגמה ויזואלית מ-Anthropic. תרגול עצמאי בקוד.</a:t>
             </a:r>
             <a:endParaRPr lang="en-US" sz="1300" dirty="0"/>
           </a:p>
@@ -36166,7 +36166,7 @@
                 <a:ea typeface="Arial" pitchFamily="34" charset="-122"/>
                 <a:cs typeface="Arial" pitchFamily="34" charset="-120"/>
               </a:rPr>
-              <a:t>הנחיה</a:t>
+              <a:t>Skills</a:t>
             </a:r>
             <a:endParaRPr lang="en-US" sz="2400" dirty="0"/>
           </a:p>
@@ -36237,7 +36237,7 @@
                 <a:ea typeface="Arial" pitchFamily="34" charset="-122"/>
                 <a:cs typeface="Arial" pitchFamily="34" charset="-120"/>
               </a:rPr>
-              <a:t>50 דק׳</a:t>
+              <a:t>30 דק׳</a:t>
             </a:r>
             <a:endParaRPr lang="en-US" sz="1100" dirty="0"/>
           </a:p>
@@ -36276,7 +36276,7 @@
                 <a:ea typeface="Arial" pitchFamily="34" charset="-122"/>
                 <a:cs typeface="Arial" pitchFamily="34" charset="-120"/>
               </a:rPr>
-              <a:t>מסגרת בת 10 רכיבים. דוגמה ויזואלית מ-Anthropic. תרגול עצמאי בקוד.</a:t>
+              <a:t>מודולי מומחיות לשימוש חוזר. UI, code review, security audit.</a:t>
             </a:r>
             <a:endParaRPr lang="en-US" sz="1300" dirty="0"/>
           </a:p>

</xml_diff>